<commit_message>
Added day 2 study materials
Kernel hardening, device tree, cvc, sbom etc
</commit_message>
<xml_diff>
--- a/yocto_training_all_session_decks/session_decks/D2S1_Recap.pptx
+++ b/yocto_training_all_session_decks/session_decks/D2S1_Recap.pptx
@@ -5,21 +5,21 @@
     <p:sldMasterId id="2147483648" r:id="rId1"/>
   </p:sldMasterIdLst>
   <p:notesMasterIdLst>
-    <p:notesMasterId r:id="rId8"/>
+    <p:notesMasterId r:id="rId6"/>
   </p:notesMasterIdLst>
   <p:handoutMasterIdLst>
-    <p:handoutMasterId r:id="rId9"/>
+    <p:handoutMasterId r:id="rId7"/>
   </p:handoutMasterIdLst>
   <p:sldIdLst>
-    <p:sldId id="1007" r:id="rId18"/>
-    <p:sldId id="1008" r:id="rId19"/>
-    <p:sldId id="1009" r:id="rId20"/>
-    <p:sldId id="1010" r:id="rId21"/>
+    <p:sldId id="1007" r:id="rId2"/>
+    <p:sldId id="1008" r:id="rId3"/>
+    <p:sldId id="1009" r:id="rId4"/>
+    <p:sldId id="1010" r:id="rId5"/>
   </p:sldIdLst>
   <p:sldSz cx="12192000" cy="6858000"/>
   <p:notesSz cx="6858000" cy="9144000"/>
   <p:custDataLst>
-    <p:tags r:id="rId10"/>
+    <p:tags r:id="rId8"/>
   </p:custDataLst>
   <p:defaultTextStyle>
     <a:defPPr>
@@ -2925,7 +2925,7 @@
           <a:p>
             <a:fld id="{0CEC647C-F50C-4F78-AA33-D7AA6CDA18EE}" type="datetimeFigureOut">
               <a:rPr lang="en-US" smtClean="0"/>
-              <a:t>7/13/2025</a:t>
+              <a:t>6/10/2026</a:t>
             </a:fld>
             <a:endParaRPr lang="en-US"/>
           </a:p>
@@ -3090,7 +3090,7 @@
           <a:p>
             <a:fld id="{3A83341F-E62C-483B-84B4-966F8BE46097}" type="datetimeFigureOut">
               <a:rPr lang="en-US" smtClean="0"/>
-              <a:t>7/13/2025</a:t>
+              <a:t>6/10/2026</a:t>
             </a:fld>
             <a:endParaRPr lang="en-US"/>
           </a:p>
@@ -5174,8 +5174,8 @@
 </p:sldMaster>
 </file>
 
-<file path=ppt/slides/slide10.xml><?xml version="1.0" encoding="utf-8"?>
-<p:sld xmlns:a="http://schemas.openxmlformats.org/drawingml/2006/main" xmlns:p="http://schemas.openxmlformats.org/presentationml/2006/main" xmlns:r="http://schemas.openxmlformats.org/officeDocument/2006/relationships">
+<file path=ppt/slides/slide1.xml><?xml version="1.0" encoding="utf-8"?>
+<p:sld xmlns:a="http://schemas.openxmlformats.org/drawingml/2006/main" xmlns:r="http://schemas.openxmlformats.org/officeDocument/2006/relationships" xmlns:p="http://schemas.openxmlformats.org/presentationml/2006/main">
   <p:cSld>
     <p:spTree>
       <p:nvGrpSpPr>
@@ -5183,7 +5183,93 @@
         <p:cNvGrpSpPr/>
         <p:nvPr/>
       </p:nvGrpSpPr>
-      <p:grpSpPr/>
+      <p:grpSpPr>
+        <a:xfrm>
+          <a:off x="0" y="0"/>
+          <a:ext cx="0" cy="0"/>
+          <a:chOff x="0" y="0"/>
+          <a:chExt cx="0" cy="0"/>
+        </a:xfrm>
+      </p:grpSpPr>
+      <p:sp>
+        <p:nvSpPr>
+          <p:cNvPr id="2" name="Title 1"/>
+          <p:cNvSpPr>
+            <a:spLocks noGrp="1"/>
+          </p:cNvSpPr>
+          <p:nvPr>
+            <p:ph type="ctrTitle"/>
+          </p:nvPr>
+        </p:nvSpPr>
+        <p:spPr/>
+        <p:txBody>
+          <a:bodyPr/>
+          <a:lstStyle/>
+          <a:p>
+            <a:r>
+              <a:rPr sz="4400" b="1">
+                <a:solidFill>
+                  <a:srgbClr val="FFFFFF"/>
+                </a:solidFill>
+                <a:latin typeface="Calibri"/>
+              </a:rPr>
+              <a:t>Day 2 Kickoff</a:t>
+            </a:r>
+          </a:p>
+        </p:txBody>
+      </p:sp>
+      <p:sp>
+        <p:nvSpPr>
+          <p:cNvPr id="3" name="Subtitle 2"/>
+          <p:cNvSpPr>
+            <a:spLocks noGrp="1"/>
+          </p:cNvSpPr>
+          <p:nvPr>
+            <p:ph type="subTitle" idx="1"/>
+          </p:nvPr>
+        </p:nvSpPr>
+        <p:spPr/>
+        <p:txBody>
+          <a:bodyPr/>
+          <a:lstStyle/>
+          <a:p>
+            <a:r>
+              <a:rPr sz="1800" dirty="0">
+                <a:solidFill>
+                  <a:srgbClr val="FFFFFF"/>
+                </a:solidFill>
+                <a:latin typeface="Calibri"/>
+              </a:rPr>
+              <a:t>Recap of Day 1, plan for Day 2</a:t>
+            </a:r>
+          </a:p>
+        </p:txBody>
+      </p:sp>
+    </p:spTree>
+  </p:cSld>
+  <p:clrMapOvr>
+    <a:masterClrMapping/>
+  </p:clrMapOvr>
+</p:sld>
+</file>
+
+<file path=ppt/slides/slide2.xml><?xml version="1.0" encoding="utf-8"?>
+<p:sld xmlns:a="http://schemas.openxmlformats.org/drawingml/2006/main" xmlns:r="http://schemas.openxmlformats.org/officeDocument/2006/relationships" xmlns:p="http://schemas.openxmlformats.org/presentationml/2006/main">
+  <p:cSld>
+    <p:spTree>
+      <p:nvGrpSpPr>
+        <p:cNvPr id="1" name=""/>
+        <p:cNvGrpSpPr/>
+        <p:nvPr/>
+      </p:nvGrpSpPr>
+      <p:grpSpPr>
+        <a:xfrm>
+          <a:off x="0" y="0"/>
+          <a:ext cx="0" cy="0"/>
+          <a:chOff x="0" y="0"/>
+          <a:chExt cx="0" cy="0"/>
+        </a:xfrm>
+      </p:grpSpPr>
       <p:sp>
         <p:nvSpPr>
           <p:cNvPr id="2" name="Title 1"/>
@@ -5200,10 +5286,731 @@
           <a:lstStyle/>
           <a:p>
             <a:r>
-              <a:rPr sz="3200" b="1">
+              <a:rPr sz="3200" b="1" dirty="0">
+                <a:latin typeface="Calibri"/>
+              </a:rPr>
+              <a:t>Session Agenda</a:t>
+            </a:r>
+          </a:p>
+        </p:txBody>
+      </p:sp>
+      <p:sp>
+        <p:nvSpPr>
+          <p:cNvPr id="3" name="TextBox 2"/>
+          <p:cNvSpPr txBox="1"/>
+          <p:nvPr/>
+        </p:nvSpPr>
+        <p:spPr>
+          <a:xfrm>
+            <a:off x="822960" y="1463040"/>
+            <a:ext cx="10515600" cy="5029200"/>
+          </a:xfrm>
+          <a:prstGeom prst="rect">
+            <a:avLst/>
+          </a:prstGeom>
+          <a:noFill/>
+        </p:spPr>
+        <p:txBody>
+          <a:bodyPr wrap="square" lIns="45720" rIns="45720">
+            <a:spAutoFit/>
+          </a:bodyPr>
+          <a:lstStyle/>
+          <a:p>
+            <a:pPr>
+              <a:spcAft>
+                <a:spcPts val="600"/>
+              </a:spcAft>
+            </a:pPr>
+            <a:r>
+              <a:rPr sz="2000" b="0" i="0">
+                <a:solidFill>
+                  <a:srgbClr val="333333"/>
+                </a:solidFill>
+                <a:latin typeface="Calibri"/>
+              </a:rPr>
+              <a:t>1.  Quick recap — Day 1 takeaways</a:t>
+            </a:r>
+          </a:p>
+          <a:p>
+            <a:pPr>
+              <a:spcAft>
+                <a:spcPts val="600"/>
+              </a:spcAft>
+            </a:pPr>
+            <a:r>
+              <a:rPr sz="2000" b="0" i="0">
+                <a:solidFill>
+                  <a:srgbClr val="333333"/>
+                </a:solidFill>
+                <a:latin typeface="Calibri"/>
+              </a:rPr>
+              <a:t>2.  Any unresolved questions?</a:t>
+            </a:r>
+          </a:p>
+          <a:p>
+            <a:pPr>
+              <a:spcAft>
+                <a:spcPts val="600"/>
+              </a:spcAft>
+            </a:pPr>
+            <a:r>
+              <a:rPr sz="2000" b="0" i="0">
+                <a:solidFill>
+                  <a:srgbClr val="333333"/>
+                </a:solidFill>
+                <a:latin typeface="Calibri"/>
+              </a:rPr>
+              <a:t>3.  Day 2 plan overview</a:t>
+            </a:r>
+          </a:p>
+          <a:p>
+            <a:pPr>
+              <a:spcAft>
+                <a:spcPts val="600"/>
+              </a:spcAft>
+            </a:pPr>
+            <a:r>
+              <a:rPr sz="2000" b="0" i="0">
+                <a:solidFill>
+                  <a:srgbClr val="333333"/>
+                </a:solidFill>
+                <a:latin typeface="Calibri"/>
+              </a:rPr>
+              <a:t>4.  Environment check</a:t>
+            </a:r>
+          </a:p>
+        </p:txBody>
+      </p:sp>
+    </p:spTree>
+  </p:cSld>
+  <p:clrMapOvr>
+    <a:masterClrMapping/>
+  </p:clrMapOvr>
+</p:sld>
+</file>
+
+<file path=ppt/slides/slide3.xml><?xml version="1.0" encoding="utf-8"?>
+<p:sld xmlns:a="http://schemas.openxmlformats.org/drawingml/2006/main" xmlns:r="http://schemas.openxmlformats.org/officeDocument/2006/relationships" xmlns:p="http://schemas.openxmlformats.org/presentationml/2006/main">
+  <p:cSld>
+    <p:spTree>
+      <p:nvGrpSpPr>
+        <p:cNvPr id="1" name=""/>
+        <p:cNvGrpSpPr/>
+        <p:nvPr/>
+      </p:nvGrpSpPr>
+      <p:grpSpPr>
+        <a:xfrm>
+          <a:off x="0" y="0"/>
+          <a:ext cx="0" cy="0"/>
+          <a:chOff x="0" y="0"/>
+          <a:chExt cx="0" cy="0"/>
+        </a:xfrm>
+      </p:grpSpPr>
+      <p:sp>
+        <p:nvSpPr>
+          <p:cNvPr id="2" name="Title 1"/>
+          <p:cNvSpPr>
+            <a:spLocks noGrp="1"/>
+          </p:cNvSpPr>
+          <p:nvPr>
+            <p:ph type="title"/>
+          </p:nvPr>
+        </p:nvSpPr>
+        <p:spPr/>
+        <p:txBody>
+          <a:bodyPr/>
+          <a:lstStyle/>
+          <a:p>
+            <a:r>
+              <a:rPr sz="3200" b="1" dirty="0">
+                <a:latin typeface="Calibri"/>
+              </a:rPr>
+              <a:t>Day 1</a:t>
+            </a:r>
+            <a:r>
+              <a:rPr lang="en-IN" sz="3200" b="1" dirty="0">
+                <a:latin typeface="Calibri"/>
+              </a:rPr>
+              <a:t>:</a:t>
+            </a:r>
+            <a:r>
+              <a:rPr sz="3200" b="1" dirty="0">
+                <a:latin typeface="Calibri"/>
+              </a:rPr>
+              <a:t> What You Now Know</a:t>
+            </a:r>
+          </a:p>
+        </p:txBody>
+      </p:sp>
+      <p:sp>
+        <p:nvSpPr>
+          <p:cNvPr id="3" name="TextBox 2"/>
+          <p:cNvSpPr txBox="1"/>
+          <p:nvPr/>
+        </p:nvSpPr>
+        <p:spPr>
+          <a:xfrm>
+            <a:off x="822960" y="1417320"/>
+            <a:ext cx="10515600" cy="338554"/>
+          </a:xfrm>
+          <a:prstGeom prst="rect">
+            <a:avLst/>
+          </a:prstGeom>
+          <a:noFill/>
+        </p:spPr>
+        <p:txBody>
+          <a:bodyPr wrap="square" lIns="45720" rIns="45720" anchor="t">
+            <a:spAutoFit/>
+          </a:bodyPr>
+          <a:lstStyle/>
+          <a:p>
+            <a:pPr algn="l"/>
+            <a:r>
+              <a:rPr sz="1600" b="0" i="1" dirty="0">
+                <a:solidFill>
+                  <a:srgbClr val="666666"/>
+                </a:solidFill>
+                <a:latin typeface="Calibri"/>
+              </a:rPr>
+              <a:t>A 30-second tour of yesterday.</a:t>
+            </a:r>
+          </a:p>
+        </p:txBody>
+      </p:sp>
+      <p:sp>
+        <p:nvSpPr>
+          <p:cNvPr id="4" name="Rounded Rectangle 3"/>
+          <p:cNvSpPr/>
+          <p:nvPr/>
+        </p:nvSpPr>
+        <p:spPr>
+          <a:xfrm>
+            <a:off x="822960" y="1874519"/>
+            <a:ext cx="457200" cy="548640"/>
+          </a:xfrm>
+          <a:prstGeom prst="roundRect">
+            <a:avLst/>
+          </a:prstGeom>
+          <a:solidFill>
+            <a:srgbClr val="663399"/>
+          </a:solidFill>
+          <a:ln>
+            <a:noFill/>
+          </a:ln>
+          <a:effectLst/>
+        </p:spPr>
+        <p:style>
+          <a:lnRef idx="1">
+            <a:schemeClr val="accent1"/>
+          </a:lnRef>
+          <a:fillRef idx="3">
+            <a:schemeClr val="accent1"/>
+          </a:fillRef>
+          <a:effectRef idx="2">
+            <a:schemeClr val="accent1"/>
+          </a:effectRef>
+          <a:fontRef idx="minor">
+            <a:schemeClr val="lt1"/>
+          </a:fontRef>
+        </p:style>
+        <p:txBody>
+          <a:bodyPr lIns="0" rIns="0" rtlCol="0" anchor="ctr"/>
+          <a:lstStyle/>
+          <a:p>
+            <a:pPr algn="ctr"/>
+            <a:r>
+              <a:rPr sz="2200" b="1">
+                <a:solidFill>
+                  <a:srgbClr val="FFFFFF"/>
+                </a:solidFill>
+                <a:latin typeface="Calibri"/>
+              </a:rPr>
+              <a:t>1</a:t>
+            </a:r>
+          </a:p>
+        </p:txBody>
+      </p:sp>
+      <p:sp>
+        <p:nvSpPr>
+          <p:cNvPr id="5" name="TextBox 4"/>
+          <p:cNvSpPr txBox="1"/>
+          <p:nvPr/>
+        </p:nvSpPr>
+        <p:spPr>
+          <a:xfrm>
+            <a:off x="1417320" y="1874519"/>
+            <a:ext cx="10058400" cy="320040"/>
+          </a:xfrm>
+          <a:prstGeom prst="rect">
+            <a:avLst/>
+          </a:prstGeom>
+          <a:noFill/>
+        </p:spPr>
+        <p:txBody>
+          <a:bodyPr wrap="square" lIns="45720" rIns="45720" anchor="t">
+            <a:spAutoFit/>
+          </a:bodyPr>
+          <a:lstStyle/>
+          <a:p>
+            <a:pPr algn="l"/>
+            <a:r>
+              <a:rPr sz="1600" b="1" i="0">
                 <a:solidFill>
                   <a:srgbClr val="CC0066"/>
                 </a:solidFill>
+                <a:latin typeface="Calibri"/>
+              </a:rPr>
+              <a:t>Linux on embedded vs desktop</a:t>
+            </a:r>
+          </a:p>
+        </p:txBody>
+      </p:sp>
+      <p:sp>
+        <p:nvSpPr>
+          <p:cNvPr id="6" name="TextBox 5"/>
+          <p:cNvSpPr txBox="1"/>
+          <p:nvPr/>
+        </p:nvSpPr>
+        <p:spPr>
+          <a:xfrm>
+            <a:off x="1417320" y="2185415"/>
+            <a:ext cx="10058400" cy="320040"/>
+          </a:xfrm>
+          <a:prstGeom prst="rect">
+            <a:avLst/>
+          </a:prstGeom>
+          <a:noFill/>
+        </p:spPr>
+        <p:txBody>
+          <a:bodyPr wrap="square" lIns="45720" rIns="45720" anchor="t">
+            <a:spAutoFit/>
+          </a:bodyPr>
+          <a:lstStyle/>
+          <a:p>
+            <a:pPr algn="l"/>
+            <a:r>
+              <a:rPr sz="1300" b="0" i="0">
+                <a:solidFill>
+                  <a:srgbClr val="333333"/>
+                </a:solidFill>
+                <a:latin typeface="Calibri"/>
+              </a:rPr>
+              <a:t>Resource constraints, cross-compile, headless reality</a:t>
+            </a:r>
+          </a:p>
+        </p:txBody>
+      </p:sp>
+      <p:sp>
+        <p:nvSpPr>
+          <p:cNvPr id="7" name="Rounded Rectangle 6"/>
+          <p:cNvSpPr/>
+          <p:nvPr/>
+        </p:nvSpPr>
+        <p:spPr>
+          <a:xfrm>
+            <a:off x="822960" y="2651760"/>
+            <a:ext cx="457200" cy="548640"/>
+          </a:xfrm>
+          <a:prstGeom prst="roundRect">
+            <a:avLst/>
+          </a:prstGeom>
+          <a:solidFill>
+            <a:srgbClr val="663399"/>
+          </a:solidFill>
+          <a:ln>
+            <a:noFill/>
+          </a:ln>
+          <a:effectLst/>
+        </p:spPr>
+        <p:style>
+          <a:lnRef idx="1">
+            <a:schemeClr val="accent1"/>
+          </a:lnRef>
+          <a:fillRef idx="3">
+            <a:schemeClr val="accent1"/>
+          </a:fillRef>
+          <a:effectRef idx="2">
+            <a:schemeClr val="accent1"/>
+          </a:effectRef>
+          <a:fontRef idx="minor">
+            <a:schemeClr val="lt1"/>
+          </a:fontRef>
+        </p:style>
+        <p:txBody>
+          <a:bodyPr lIns="0" rIns="0" rtlCol="0" anchor="ctr"/>
+          <a:lstStyle/>
+          <a:p>
+            <a:pPr algn="ctr"/>
+            <a:r>
+              <a:rPr sz="2200" b="1">
+                <a:solidFill>
+                  <a:srgbClr val="FFFFFF"/>
+                </a:solidFill>
+                <a:latin typeface="Calibri"/>
+              </a:rPr>
+              <a:t>2</a:t>
+            </a:r>
+          </a:p>
+        </p:txBody>
+      </p:sp>
+      <p:sp>
+        <p:nvSpPr>
+          <p:cNvPr id="8" name="TextBox 7"/>
+          <p:cNvSpPr txBox="1"/>
+          <p:nvPr/>
+        </p:nvSpPr>
+        <p:spPr>
+          <a:xfrm>
+            <a:off x="1417320" y="2651760"/>
+            <a:ext cx="10058400" cy="320040"/>
+          </a:xfrm>
+          <a:prstGeom prst="rect">
+            <a:avLst/>
+          </a:prstGeom>
+          <a:noFill/>
+        </p:spPr>
+        <p:txBody>
+          <a:bodyPr wrap="square" lIns="45720" rIns="45720" anchor="t">
+            <a:spAutoFit/>
+          </a:bodyPr>
+          <a:lstStyle/>
+          <a:p>
+            <a:pPr algn="l"/>
+            <a:r>
+              <a:rPr sz="1600" b="1" i="0">
+                <a:solidFill>
+                  <a:srgbClr val="CC0066"/>
+                </a:solidFill>
+                <a:latin typeface="Calibri"/>
+              </a:rPr>
+              <a:t>Yocto = framework, not distro</a:t>
+            </a:r>
+          </a:p>
+        </p:txBody>
+      </p:sp>
+      <p:sp>
+        <p:nvSpPr>
+          <p:cNvPr id="9" name="TextBox 8"/>
+          <p:cNvSpPr txBox="1"/>
+          <p:nvPr/>
+        </p:nvSpPr>
+        <p:spPr>
+          <a:xfrm>
+            <a:off x="1417320" y="2962656"/>
+            <a:ext cx="10058400" cy="320040"/>
+          </a:xfrm>
+          <a:prstGeom prst="rect">
+            <a:avLst/>
+          </a:prstGeom>
+          <a:noFill/>
+        </p:spPr>
+        <p:txBody>
+          <a:bodyPr wrap="square" lIns="45720" rIns="45720" anchor="t">
+            <a:spAutoFit/>
+          </a:bodyPr>
+          <a:lstStyle/>
+          <a:p>
+            <a:pPr algn="l"/>
+            <a:r>
+              <a:rPr sz="1300" b="0" i="0">
+                <a:solidFill>
+                  <a:srgbClr val="333333"/>
+                </a:solidFill>
+                <a:latin typeface="Calibri"/>
+              </a:rPr>
+              <a:t>Poky + BitBake + layers; you compose your product</a:t>
+            </a:r>
+          </a:p>
+        </p:txBody>
+      </p:sp>
+      <p:sp>
+        <p:nvSpPr>
+          <p:cNvPr id="10" name="Rounded Rectangle 9"/>
+          <p:cNvSpPr/>
+          <p:nvPr/>
+        </p:nvSpPr>
+        <p:spPr>
+          <a:xfrm>
+            <a:off x="822960" y="3429000"/>
+            <a:ext cx="457200" cy="548640"/>
+          </a:xfrm>
+          <a:prstGeom prst="roundRect">
+            <a:avLst/>
+          </a:prstGeom>
+          <a:solidFill>
+            <a:srgbClr val="663399"/>
+          </a:solidFill>
+          <a:ln>
+            <a:noFill/>
+          </a:ln>
+          <a:effectLst/>
+        </p:spPr>
+        <p:style>
+          <a:lnRef idx="1">
+            <a:schemeClr val="accent1"/>
+          </a:lnRef>
+          <a:fillRef idx="3">
+            <a:schemeClr val="accent1"/>
+          </a:fillRef>
+          <a:effectRef idx="2">
+            <a:schemeClr val="accent1"/>
+          </a:effectRef>
+          <a:fontRef idx="minor">
+            <a:schemeClr val="lt1"/>
+          </a:fontRef>
+        </p:style>
+        <p:txBody>
+          <a:bodyPr lIns="0" rIns="0" rtlCol="0" anchor="ctr"/>
+          <a:lstStyle/>
+          <a:p>
+            <a:pPr algn="ctr"/>
+            <a:r>
+              <a:rPr sz="2200" b="1">
+                <a:solidFill>
+                  <a:srgbClr val="FFFFFF"/>
+                </a:solidFill>
+                <a:latin typeface="Calibri"/>
+              </a:rPr>
+              <a:t>3</a:t>
+            </a:r>
+          </a:p>
+        </p:txBody>
+      </p:sp>
+      <p:sp>
+        <p:nvSpPr>
+          <p:cNvPr id="11" name="TextBox 10"/>
+          <p:cNvSpPr txBox="1"/>
+          <p:nvPr/>
+        </p:nvSpPr>
+        <p:spPr>
+          <a:xfrm>
+            <a:off x="1417320" y="3429000"/>
+            <a:ext cx="10058400" cy="320040"/>
+          </a:xfrm>
+          <a:prstGeom prst="rect">
+            <a:avLst/>
+          </a:prstGeom>
+          <a:noFill/>
+        </p:spPr>
+        <p:txBody>
+          <a:bodyPr wrap="square" lIns="45720" rIns="45720" anchor="t">
+            <a:spAutoFit/>
+          </a:bodyPr>
+          <a:lstStyle/>
+          <a:p>
+            <a:pPr algn="l"/>
+            <a:r>
+              <a:rPr sz="1600" b="1" i="0">
+                <a:solidFill>
+                  <a:srgbClr val="CC0066"/>
+                </a:solidFill>
+                <a:latin typeface="Calibri"/>
+              </a:rPr>
+              <a:t>BitBake parses, plans, executes</a:t>
+            </a:r>
+          </a:p>
+        </p:txBody>
+      </p:sp>
+      <p:sp>
+        <p:nvSpPr>
+          <p:cNvPr id="12" name="TextBox 11"/>
+          <p:cNvSpPr txBox="1"/>
+          <p:nvPr/>
+        </p:nvSpPr>
+        <p:spPr>
+          <a:xfrm>
+            <a:off x="1417320" y="3739896"/>
+            <a:ext cx="10058400" cy="320040"/>
+          </a:xfrm>
+          <a:prstGeom prst="rect">
+            <a:avLst/>
+          </a:prstGeom>
+          <a:noFill/>
+        </p:spPr>
+        <p:txBody>
+          <a:bodyPr wrap="square" lIns="45720" rIns="45720" anchor="t">
+            <a:spAutoFit/>
+          </a:bodyPr>
+          <a:lstStyle/>
+          <a:p>
+            <a:pPr algn="l"/>
+            <a:r>
+              <a:rPr sz="1300" b="0" i="0">
+                <a:solidFill>
+                  <a:srgbClr val="333333"/>
+                </a:solidFill>
+                <a:latin typeface="Calibri"/>
+              </a:rPr>
+              <a:t>Task graph + sstate cache = scalable builds</a:t>
+            </a:r>
+          </a:p>
+        </p:txBody>
+      </p:sp>
+      <p:sp>
+        <p:nvSpPr>
+          <p:cNvPr id="13" name="Rounded Rectangle 12"/>
+          <p:cNvSpPr/>
+          <p:nvPr/>
+        </p:nvSpPr>
+        <p:spPr>
+          <a:xfrm>
+            <a:off x="822960" y="4206240"/>
+            <a:ext cx="457200" cy="548640"/>
+          </a:xfrm>
+          <a:prstGeom prst="roundRect">
+            <a:avLst/>
+          </a:prstGeom>
+          <a:solidFill>
+            <a:srgbClr val="663399"/>
+          </a:solidFill>
+          <a:ln>
+            <a:noFill/>
+          </a:ln>
+          <a:effectLst/>
+        </p:spPr>
+        <p:style>
+          <a:lnRef idx="1">
+            <a:schemeClr val="accent1"/>
+          </a:lnRef>
+          <a:fillRef idx="3">
+            <a:schemeClr val="accent1"/>
+          </a:fillRef>
+          <a:effectRef idx="2">
+            <a:schemeClr val="accent1"/>
+          </a:effectRef>
+          <a:fontRef idx="minor">
+            <a:schemeClr val="lt1"/>
+          </a:fontRef>
+        </p:style>
+        <p:txBody>
+          <a:bodyPr lIns="0" rIns="0" rtlCol="0" anchor="ctr"/>
+          <a:lstStyle/>
+          <a:p>
+            <a:pPr algn="ctr"/>
+            <a:r>
+              <a:rPr sz="2200" b="1">
+                <a:solidFill>
+                  <a:srgbClr val="FFFFFF"/>
+                </a:solidFill>
+                <a:latin typeface="Calibri"/>
+              </a:rPr>
+              <a:t>4</a:t>
+            </a:r>
+          </a:p>
+        </p:txBody>
+      </p:sp>
+      <p:sp>
+        <p:nvSpPr>
+          <p:cNvPr id="14" name="TextBox 13"/>
+          <p:cNvSpPr txBox="1"/>
+          <p:nvPr/>
+        </p:nvSpPr>
+        <p:spPr>
+          <a:xfrm>
+            <a:off x="1417320" y="4206240"/>
+            <a:ext cx="10058400" cy="320040"/>
+          </a:xfrm>
+          <a:prstGeom prst="rect">
+            <a:avLst/>
+          </a:prstGeom>
+          <a:noFill/>
+        </p:spPr>
+        <p:txBody>
+          <a:bodyPr wrap="square" lIns="45720" rIns="45720" anchor="t">
+            <a:spAutoFit/>
+          </a:bodyPr>
+          <a:lstStyle/>
+          <a:p>
+            <a:pPr algn="l"/>
+            <a:r>
+              <a:rPr sz="1600" b="1" i="0">
+                <a:solidFill>
+                  <a:srgbClr val="CC0066"/>
+                </a:solidFill>
+                <a:latin typeface="Calibri"/>
+              </a:rPr>
+              <a:t>First custom image built</a:t>
+            </a:r>
+          </a:p>
+        </p:txBody>
+      </p:sp>
+      <p:sp>
+        <p:nvSpPr>
+          <p:cNvPr id="15" name="TextBox 14"/>
+          <p:cNvSpPr txBox="1"/>
+          <p:nvPr/>
+        </p:nvSpPr>
+        <p:spPr>
+          <a:xfrm>
+            <a:off x="1417320" y="4517136"/>
+            <a:ext cx="10058400" cy="320040"/>
+          </a:xfrm>
+          <a:prstGeom prst="rect">
+            <a:avLst/>
+          </a:prstGeom>
+          <a:noFill/>
+        </p:spPr>
+        <p:txBody>
+          <a:bodyPr wrap="square" lIns="45720" rIns="45720" anchor="t">
+            <a:spAutoFit/>
+          </a:bodyPr>
+          <a:lstStyle/>
+          <a:p>
+            <a:pPr algn="l"/>
+            <a:r>
+              <a:rPr sz="1300" b="0" i="0">
+                <a:solidFill>
+                  <a:srgbClr val="333333"/>
+                </a:solidFill>
+                <a:latin typeface="Calibri"/>
+              </a:rPr>
+              <a:t>meta-trainerdemo + hello-trainergw in your IMAGE_INSTALL</a:t>
+            </a:r>
+          </a:p>
+        </p:txBody>
+      </p:sp>
+    </p:spTree>
+  </p:cSld>
+  <p:clrMapOvr>
+    <a:masterClrMapping/>
+  </p:clrMapOvr>
+</p:sld>
+</file>
+
+<file path=ppt/slides/slide4.xml><?xml version="1.0" encoding="utf-8"?>
+<p:sld xmlns:a="http://schemas.openxmlformats.org/drawingml/2006/main" xmlns:r="http://schemas.openxmlformats.org/officeDocument/2006/relationships" xmlns:p="http://schemas.openxmlformats.org/presentationml/2006/main">
+  <p:cSld>
+    <p:spTree>
+      <p:nvGrpSpPr>
+        <p:cNvPr id="1" name=""/>
+        <p:cNvGrpSpPr/>
+        <p:nvPr/>
+      </p:nvGrpSpPr>
+      <p:grpSpPr>
+        <a:xfrm>
+          <a:off x="0" y="0"/>
+          <a:ext cx="0" cy="0"/>
+          <a:chOff x="0" y="0"/>
+          <a:chExt cx="0" cy="0"/>
+        </a:xfrm>
+      </p:grpSpPr>
+      <p:sp>
+        <p:nvSpPr>
+          <p:cNvPr id="2" name="Title 1"/>
+          <p:cNvSpPr>
+            <a:spLocks noGrp="1"/>
+          </p:cNvSpPr>
+          <p:nvPr>
+            <p:ph type="title"/>
+          </p:nvPr>
+        </p:nvSpPr>
+        <p:spPr/>
+        <p:txBody>
+          <a:bodyPr/>
+          <a:lstStyle/>
+          <a:p>
+            <a:r>
+              <a:rPr sz="3200" b="1" dirty="0">
                 <a:latin typeface="Calibri"/>
               </a:rPr>
               <a:t>Day 2 Plan</a:t>
@@ -5228,7 +6035,7 @@
           <a:noFill/>
         </p:spPr>
         <p:txBody>
-          <a:bodyPr wrap="square" anchor="t" lIns="45720" rIns="45720">
+          <a:bodyPr wrap="square" lIns="45720" rIns="45720" anchor="t">
             <a:spAutoFit/>
           </a:bodyPr>
           <a:lstStyle/>
@@ -5289,6 +6096,7 @@
           <a:lstStyle/>
           <a:p>
             <a:pPr algn="ctr"/>
+            <a:endParaRPr/>
           </a:p>
         </p:txBody>
       </p:sp>
@@ -5309,7 +6117,7 @@
           <a:noFill/>
         </p:spPr>
         <p:txBody>
-          <a:bodyPr wrap="square" anchor="t" lIns="45720" rIns="45720">
+          <a:bodyPr wrap="square" lIns="45720" rIns="45720" anchor="t">
             <a:spAutoFit/>
           </a:bodyPr>
           <a:lstStyle/>
@@ -5336,7 +6144,7 @@
         <p:spPr>
           <a:xfrm>
             <a:off x="960120" y="2560320"/>
-            <a:ext cx="4937760" cy="3337560"/>
+            <a:ext cx="4937760" cy="1851789"/>
           </a:xfrm>
           <a:prstGeom prst="rect">
             <a:avLst/>
@@ -5355,7 +6163,7 @@
               </a:spcAft>
             </a:pPr>
             <a:r>
-              <a:rPr sz="1300" b="1" i="0">
+              <a:rPr sz="1600" b="1" i="0">
                 <a:solidFill>
                   <a:srgbClr val="CC0066"/>
                 </a:solidFill>
@@ -5371,7 +6179,7 @@
               </a:spcAft>
             </a:pPr>
             <a:r>
-              <a:rPr sz="1200" b="0" i="0">
+              <a:rPr sz="1600" b="0" i="0">
                 <a:solidFill>
                   <a:srgbClr val="333333"/>
                 </a:solidFill>
@@ -5387,7 +6195,7 @@
               </a:spcAft>
             </a:pPr>
             <a:r>
-              <a:rPr sz="1300" b="1" i="0">
+              <a:rPr sz="1600" b="1" i="0">
                 <a:solidFill>
                   <a:srgbClr val="CC0066"/>
                 </a:solidFill>
@@ -5403,7 +6211,7 @@
               </a:spcAft>
             </a:pPr>
             <a:r>
-              <a:rPr sz="1200" b="0" i="0">
+              <a:rPr sz="1600" b="0" i="0">
                 <a:solidFill>
                   <a:srgbClr val="333333"/>
                 </a:solidFill>
@@ -5419,7 +6227,7 @@
               </a:spcAft>
             </a:pPr>
             <a:r>
-              <a:rPr sz="1300" b="1" i="0">
+              <a:rPr sz="1600" b="1" i="0">
                 <a:solidFill>
                   <a:srgbClr val="CC0066"/>
                 </a:solidFill>
@@ -5435,7 +6243,7 @@
               </a:spcAft>
             </a:pPr>
             <a:r>
-              <a:rPr sz="1200" b="0" i="0">
+              <a:rPr sz="1600" b="0" i="0">
                 <a:solidFill>
                   <a:srgbClr val="333333"/>
                 </a:solidFill>
@@ -5489,6 +6297,7 @@
           <a:lstStyle/>
           <a:p>
             <a:pPr algn="ctr"/>
+            <a:endParaRPr/>
           </a:p>
         </p:txBody>
       </p:sp>
@@ -5509,7 +6318,7 @@
           <a:noFill/>
         </p:spPr>
         <p:txBody>
-          <a:bodyPr wrap="square" anchor="t" lIns="45720" rIns="45720">
+          <a:bodyPr wrap="square" lIns="45720" rIns="45720" anchor="t">
             <a:spAutoFit/>
           </a:bodyPr>
           <a:lstStyle/>
@@ -5536,7 +6345,7 @@
         <p:spPr>
           <a:xfrm>
             <a:off x="6400800" y="2560320"/>
-            <a:ext cx="4937760" cy="3337560"/>
+            <a:ext cx="4937760" cy="2098010"/>
           </a:xfrm>
           <a:prstGeom prst="rect">
             <a:avLst/>
@@ -5555,7 +6364,7 @@
               </a:spcAft>
             </a:pPr>
             <a:r>
-              <a:rPr sz="1300" b="1" i="0">
+              <a:rPr sz="1600" b="1" i="0">
                 <a:solidFill>
                   <a:srgbClr val="663399"/>
                 </a:solidFill>
@@ -5571,7 +6380,7 @@
               </a:spcAft>
             </a:pPr>
             <a:r>
-              <a:rPr sz="1200" b="0" i="0">
+              <a:rPr sz="1600" b="0" i="0">
                 <a:solidFill>
                   <a:srgbClr val="333333"/>
                 </a:solidFill>
@@ -5587,7 +6396,7 @@
               </a:spcAft>
             </a:pPr>
             <a:r>
-              <a:rPr sz="1300" b="1" i="0">
+              <a:rPr sz="1600" b="1" i="0">
                 <a:solidFill>
                   <a:srgbClr val="663399"/>
                 </a:solidFill>
@@ -5603,7 +6412,7 @@
               </a:spcAft>
             </a:pPr>
             <a:r>
-              <a:rPr sz="1200" b="0" i="0">
+              <a:rPr sz="1600" b="0" i="0">
                 <a:solidFill>
                   <a:srgbClr val="333333"/>
                 </a:solidFill>
@@ -5619,7 +6428,7 @@
               </a:spcAft>
             </a:pPr>
             <a:r>
-              <a:rPr sz="1300" b="1" i="0">
+              <a:rPr sz="1600" b="1" i="0">
                 <a:solidFill>
                   <a:srgbClr val="663399"/>
                 </a:solidFill>
@@ -5635,800 +6444,13 @@
               </a:spcAft>
             </a:pPr>
             <a:r>
-              <a:rPr sz="1200" b="0" i="0">
+              <a:rPr sz="1600" b="0" i="0">
                 <a:solidFill>
                   <a:srgbClr val="333333"/>
                 </a:solidFill>
                 <a:latin typeface="Calibri"/>
               </a:rPr>
               <a:t>Hands-on lab — apply everything</a:t>
-            </a:r>
-          </a:p>
-        </p:txBody>
-      </p:sp>
-    </p:spTree>
-  </p:cSld>
-  <p:clrMapOvr>
-    <a:masterClrMapping/>
-  </p:clrMapOvr>
-</p:sld>
-</file>
-
-<file path=ppt/slides/slide7.xml><?xml version="1.0" encoding="utf-8"?>
-<p:sld xmlns:a="http://schemas.openxmlformats.org/drawingml/2006/main" xmlns:p="http://schemas.openxmlformats.org/presentationml/2006/main" xmlns:r="http://schemas.openxmlformats.org/officeDocument/2006/relationships">
-  <p:cSld>
-    <p:spTree>
-      <p:nvGrpSpPr>
-        <p:cNvPr id="1" name=""/>
-        <p:cNvGrpSpPr/>
-        <p:nvPr/>
-      </p:nvGrpSpPr>
-      <p:grpSpPr/>
-      <p:sp>
-        <p:nvSpPr>
-          <p:cNvPr id="2" name="Title 1"/>
-          <p:cNvSpPr>
-            <a:spLocks noGrp="1"/>
-          </p:cNvSpPr>
-          <p:nvPr>
-            <p:ph type="ctrTitle"/>
-          </p:nvPr>
-        </p:nvSpPr>
-        <p:spPr/>
-        <p:txBody>
-          <a:bodyPr/>
-          <a:lstStyle/>
-          <a:p>
-            <a:r>
-              <a:rPr sz="4400" b="1">
-                <a:solidFill>
-                  <a:srgbClr val="FFFFFF"/>
-                </a:solidFill>
-                <a:latin typeface="Calibri"/>
-              </a:rPr>
-              <a:t>Day 2 Kickoff</a:t>
-            </a:r>
-          </a:p>
-        </p:txBody>
-      </p:sp>
-      <p:sp>
-        <p:nvSpPr>
-          <p:cNvPr id="3" name="Subtitle 2"/>
-          <p:cNvSpPr>
-            <a:spLocks noGrp="1"/>
-          </p:cNvSpPr>
-          <p:nvPr>
-            <p:ph type="subTitle" idx="1"/>
-          </p:nvPr>
-        </p:nvSpPr>
-        <p:spPr/>
-        <p:txBody>
-          <a:bodyPr/>
-          <a:lstStyle/>
-          <a:p>
-            <a:r>
-              <a:rPr sz="2200" i="1">
-                <a:solidFill>
-                  <a:srgbClr val="FFFFFF"/>
-                </a:solidFill>
-                <a:latin typeface="Calibri"/>
-              </a:rPr>
-              <a:t>Day 2 • Session 1 • 15 minutes</a:t>
-            </a:r>
-          </a:p>
-          <a:p>
-            <a:r>
-              <a:rPr sz="1800">
-                <a:solidFill>
-                  <a:srgbClr val="FFFFFF"/>
-                </a:solidFill>
-                <a:latin typeface="Calibri"/>
-              </a:rPr>
-              <a:t>Recap of Day 1, plan for Day 2</a:t>
-            </a:r>
-          </a:p>
-        </p:txBody>
-      </p:sp>
-    </p:spTree>
-  </p:cSld>
-  <p:clrMapOvr>
-    <a:masterClrMapping/>
-  </p:clrMapOvr>
-</p:sld>
-</file>
-
-<file path=ppt/slides/slide8.xml><?xml version="1.0" encoding="utf-8"?>
-<p:sld xmlns:a="http://schemas.openxmlformats.org/drawingml/2006/main" xmlns:p="http://schemas.openxmlformats.org/presentationml/2006/main" xmlns:r="http://schemas.openxmlformats.org/officeDocument/2006/relationships">
-  <p:cSld>
-    <p:spTree>
-      <p:nvGrpSpPr>
-        <p:cNvPr id="1" name=""/>
-        <p:cNvGrpSpPr/>
-        <p:nvPr/>
-      </p:nvGrpSpPr>
-      <p:grpSpPr/>
-      <p:sp>
-        <p:nvSpPr>
-          <p:cNvPr id="2" name="Title 1"/>
-          <p:cNvSpPr>
-            <a:spLocks noGrp="1"/>
-          </p:cNvSpPr>
-          <p:nvPr>
-            <p:ph type="title"/>
-          </p:nvPr>
-        </p:nvSpPr>
-        <p:spPr/>
-        <p:txBody>
-          <a:bodyPr/>
-          <a:lstStyle/>
-          <a:p>
-            <a:r>
-              <a:rPr sz="3200" b="1">
-                <a:solidFill>
-                  <a:srgbClr val="CC0066"/>
-                </a:solidFill>
-                <a:latin typeface="Calibri"/>
-              </a:rPr>
-              <a:t>Session Agenda</a:t>
-            </a:r>
-          </a:p>
-        </p:txBody>
-      </p:sp>
-      <p:sp>
-        <p:nvSpPr>
-          <p:cNvPr id="3" name="TextBox 2"/>
-          <p:cNvSpPr txBox="1"/>
-          <p:nvPr/>
-        </p:nvSpPr>
-        <p:spPr>
-          <a:xfrm>
-            <a:off x="822960" y="1463040"/>
-            <a:ext cx="10515600" cy="5029200"/>
-          </a:xfrm>
-          <a:prstGeom prst="rect">
-            <a:avLst/>
-          </a:prstGeom>
-          <a:noFill/>
-        </p:spPr>
-        <p:txBody>
-          <a:bodyPr wrap="square" lIns="45720" rIns="45720">
-            <a:spAutoFit/>
-          </a:bodyPr>
-          <a:lstStyle/>
-          <a:p>
-            <a:pPr>
-              <a:spcAft>
-                <a:spcPts val="600"/>
-              </a:spcAft>
-            </a:pPr>
-            <a:r>
-              <a:rPr sz="2000" b="0" i="0">
-                <a:solidFill>
-                  <a:srgbClr val="333333"/>
-                </a:solidFill>
-                <a:latin typeface="Calibri"/>
-              </a:rPr>
-              <a:t>1.  Quick recap — Day 1 takeaways</a:t>
-            </a:r>
-          </a:p>
-          <a:p>
-            <a:pPr>
-              <a:spcAft>
-                <a:spcPts val="600"/>
-              </a:spcAft>
-            </a:pPr>
-            <a:r>
-              <a:rPr sz="2000" b="0" i="0">
-                <a:solidFill>
-                  <a:srgbClr val="333333"/>
-                </a:solidFill>
-                <a:latin typeface="Calibri"/>
-              </a:rPr>
-              <a:t>2.  Any unresolved questions?</a:t>
-            </a:r>
-          </a:p>
-          <a:p>
-            <a:pPr>
-              <a:spcAft>
-                <a:spcPts val="600"/>
-              </a:spcAft>
-            </a:pPr>
-            <a:r>
-              <a:rPr sz="2000" b="0" i="0">
-                <a:solidFill>
-                  <a:srgbClr val="333333"/>
-                </a:solidFill>
-                <a:latin typeface="Calibri"/>
-              </a:rPr>
-              <a:t>3.  Day 2 plan overview</a:t>
-            </a:r>
-          </a:p>
-          <a:p>
-            <a:pPr>
-              <a:spcAft>
-                <a:spcPts val="600"/>
-              </a:spcAft>
-            </a:pPr>
-            <a:r>
-              <a:rPr sz="2000" b="0" i="0">
-                <a:solidFill>
-                  <a:srgbClr val="333333"/>
-                </a:solidFill>
-                <a:latin typeface="Calibri"/>
-              </a:rPr>
-              <a:t>4.  Environment check</a:t>
-            </a:r>
-          </a:p>
-        </p:txBody>
-      </p:sp>
-    </p:spTree>
-  </p:cSld>
-  <p:clrMapOvr>
-    <a:masterClrMapping/>
-  </p:clrMapOvr>
-</p:sld>
-</file>
-
-<file path=ppt/slides/slide9.xml><?xml version="1.0" encoding="utf-8"?>
-<p:sld xmlns:a="http://schemas.openxmlformats.org/drawingml/2006/main" xmlns:p="http://schemas.openxmlformats.org/presentationml/2006/main" xmlns:r="http://schemas.openxmlformats.org/officeDocument/2006/relationships">
-  <p:cSld>
-    <p:spTree>
-      <p:nvGrpSpPr>
-        <p:cNvPr id="1" name=""/>
-        <p:cNvGrpSpPr/>
-        <p:nvPr/>
-      </p:nvGrpSpPr>
-      <p:grpSpPr/>
-      <p:sp>
-        <p:nvSpPr>
-          <p:cNvPr id="2" name="Title 1"/>
-          <p:cNvSpPr>
-            <a:spLocks noGrp="1"/>
-          </p:cNvSpPr>
-          <p:nvPr>
-            <p:ph type="title"/>
-          </p:nvPr>
-        </p:nvSpPr>
-        <p:spPr/>
-        <p:txBody>
-          <a:bodyPr/>
-          <a:lstStyle/>
-          <a:p>
-            <a:r>
-              <a:rPr sz="3200" b="1">
-                <a:solidFill>
-                  <a:srgbClr val="CC0066"/>
-                </a:solidFill>
-                <a:latin typeface="Calibri"/>
-              </a:rPr>
-              <a:t>Day 1 — What You Now Know</a:t>
-            </a:r>
-          </a:p>
-        </p:txBody>
-      </p:sp>
-      <p:sp>
-        <p:nvSpPr>
-          <p:cNvPr id="3" name="TextBox 2"/>
-          <p:cNvSpPr txBox="1"/>
-          <p:nvPr/>
-        </p:nvSpPr>
-        <p:spPr>
-          <a:xfrm>
-            <a:off x="822960" y="1417320"/>
-            <a:ext cx="10515600" cy="365760"/>
-          </a:xfrm>
-          <a:prstGeom prst="rect">
-            <a:avLst/>
-          </a:prstGeom>
-          <a:noFill/>
-        </p:spPr>
-        <p:txBody>
-          <a:bodyPr wrap="square" anchor="t" lIns="45720" rIns="45720">
-            <a:spAutoFit/>
-          </a:bodyPr>
-          <a:lstStyle/>
-          <a:p>
-            <a:pPr algn="l"/>
-            <a:r>
-              <a:rPr sz="1500" b="0" i="1">
-                <a:solidFill>
-                  <a:srgbClr val="666666"/>
-                </a:solidFill>
-                <a:latin typeface="Calibri"/>
-              </a:rPr>
-              <a:t>A 30-second tour of yesterday.</a:t>
-            </a:r>
-          </a:p>
-        </p:txBody>
-      </p:sp>
-      <p:sp>
-        <p:nvSpPr>
-          <p:cNvPr id="4" name="Rounded Rectangle 3"/>
-          <p:cNvSpPr/>
-          <p:nvPr/>
-        </p:nvSpPr>
-        <p:spPr>
-          <a:xfrm>
-            <a:off x="822960" y="1874519"/>
-            <a:ext cx="457200" cy="548640"/>
-          </a:xfrm>
-          <a:prstGeom prst="roundRect">
-            <a:avLst/>
-          </a:prstGeom>
-          <a:solidFill>
-            <a:srgbClr val="663399"/>
-          </a:solidFill>
-          <a:ln>
-            <a:noFill/>
-          </a:ln>
-          <a:effectLst/>
-        </p:spPr>
-        <p:style>
-          <a:lnRef idx="1">
-            <a:schemeClr val="accent1"/>
-          </a:lnRef>
-          <a:fillRef idx="3">
-            <a:schemeClr val="accent1"/>
-          </a:fillRef>
-          <a:effectRef idx="2">
-            <a:schemeClr val="accent1"/>
-          </a:effectRef>
-          <a:fontRef idx="minor">
-            <a:schemeClr val="lt1"/>
-          </a:fontRef>
-        </p:style>
-        <p:txBody>
-          <a:bodyPr rtlCol="0" anchor="ctr" lIns="0" rIns="0"/>
-          <a:lstStyle/>
-          <a:p>
-            <a:pPr algn="ctr"/>
-            <a:r>
-              <a:rPr sz="2200" b="1">
-                <a:solidFill>
-                  <a:srgbClr val="FFFFFF"/>
-                </a:solidFill>
-                <a:latin typeface="Calibri"/>
-              </a:rPr>
-              <a:t>1</a:t>
-            </a:r>
-          </a:p>
-        </p:txBody>
-      </p:sp>
-      <p:sp>
-        <p:nvSpPr>
-          <p:cNvPr id="5" name="TextBox 4"/>
-          <p:cNvSpPr txBox="1"/>
-          <p:nvPr/>
-        </p:nvSpPr>
-        <p:spPr>
-          <a:xfrm>
-            <a:off x="1417320" y="1874519"/>
-            <a:ext cx="10058400" cy="320040"/>
-          </a:xfrm>
-          <a:prstGeom prst="rect">
-            <a:avLst/>
-          </a:prstGeom>
-          <a:noFill/>
-        </p:spPr>
-        <p:txBody>
-          <a:bodyPr wrap="square" anchor="t" lIns="45720" rIns="45720">
-            <a:spAutoFit/>
-          </a:bodyPr>
-          <a:lstStyle/>
-          <a:p>
-            <a:pPr algn="l"/>
-            <a:r>
-              <a:rPr sz="1600" b="1" i="0">
-                <a:solidFill>
-                  <a:srgbClr val="CC0066"/>
-                </a:solidFill>
-                <a:latin typeface="Calibri"/>
-              </a:rPr>
-              <a:t>Linux on embedded vs desktop</a:t>
-            </a:r>
-          </a:p>
-        </p:txBody>
-      </p:sp>
-      <p:sp>
-        <p:nvSpPr>
-          <p:cNvPr id="6" name="TextBox 5"/>
-          <p:cNvSpPr txBox="1"/>
-          <p:nvPr/>
-        </p:nvSpPr>
-        <p:spPr>
-          <a:xfrm>
-            <a:off x="1417320" y="2185415"/>
-            <a:ext cx="10058400" cy="320040"/>
-          </a:xfrm>
-          <a:prstGeom prst="rect">
-            <a:avLst/>
-          </a:prstGeom>
-          <a:noFill/>
-        </p:spPr>
-        <p:txBody>
-          <a:bodyPr wrap="square" anchor="t" lIns="45720" rIns="45720">
-            <a:spAutoFit/>
-          </a:bodyPr>
-          <a:lstStyle/>
-          <a:p>
-            <a:pPr algn="l"/>
-            <a:r>
-              <a:rPr sz="1300" b="0" i="0">
-                <a:solidFill>
-                  <a:srgbClr val="333333"/>
-                </a:solidFill>
-                <a:latin typeface="Calibri"/>
-              </a:rPr>
-              <a:t>Resource constraints, cross-compile, headless reality</a:t>
-            </a:r>
-          </a:p>
-        </p:txBody>
-      </p:sp>
-      <p:sp>
-        <p:nvSpPr>
-          <p:cNvPr id="7" name="Rounded Rectangle 6"/>
-          <p:cNvSpPr/>
-          <p:nvPr/>
-        </p:nvSpPr>
-        <p:spPr>
-          <a:xfrm>
-            <a:off x="822960" y="2651760"/>
-            <a:ext cx="457200" cy="548640"/>
-          </a:xfrm>
-          <a:prstGeom prst="roundRect">
-            <a:avLst/>
-          </a:prstGeom>
-          <a:solidFill>
-            <a:srgbClr val="663399"/>
-          </a:solidFill>
-          <a:ln>
-            <a:noFill/>
-          </a:ln>
-          <a:effectLst/>
-        </p:spPr>
-        <p:style>
-          <a:lnRef idx="1">
-            <a:schemeClr val="accent1"/>
-          </a:lnRef>
-          <a:fillRef idx="3">
-            <a:schemeClr val="accent1"/>
-          </a:fillRef>
-          <a:effectRef idx="2">
-            <a:schemeClr val="accent1"/>
-          </a:effectRef>
-          <a:fontRef idx="minor">
-            <a:schemeClr val="lt1"/>
-          </a:fontRef>
-        </p:style>
-        <p:txBody>
-          <a:bodyPr rtlCol="0" anchor="ctr" lIns="0" rIns="0"/>
-          <a:lstStyle/>
-          <a:p>
-            <a:pPr algn="ctr"/>
-            <a:r>
-              <a:rPr sz="2200" b="1">
-                <a:solidFill>
-                  <a:srgbClr val="FFFFFF"/>
-                </a:solidFill>
-                <a:latin typeface="Calibri"/>
-              </a:rPr>
-              <a:t>2</a:t>
-            </a:r>
-          </a:p>
-        </p:txBody>
-      </p:sp>
-      <p:sp>
-        <p:nvSpPr>
-          <p:cNvPr id="8" name="TextBox 7"/>
-          <p:cNvSpPr txBox="1"/>
-          <p:nvPr/>
-        </p:nvSpPr>
-        <p:spPr>
-          <a:xfrm>
-            <a:off x="1417320" y="2651760"/>
-            <a:ext cx="10058400" cy="320040"/>
-          </a:xfrm>
-          <a:prstGeom prst="rect">
-            <a:avLst/>
-          </a:prstGeom>
-          <a:noFill/>
-        </p:spPr>
-        <p:txBody>
-          <a:bodyPr wrap="square" anchor="t" lIns="45720" rIns="45720">
-            <a:spAutoFit/>
-          </a:bodyPr>
-          <a:lstStyle/>
-          <a:p>
-            <a:pPr algn="l"/>
-            <a:r>
-              <a:rPr sz="1600" b="1" i="0">
-                <a:solidFill>
-                  <a:srgbClr val="CC0066"/>
-                </a:solidFill>
-                <a:latin typeface="Calibri"/>
-              </a:rPr>
-              <a:t>Yocto = framework, not distro</a:t>
-            </a:r>
-          </a:p>
-        </p:txBody>
-      </p:sp>
-      <p:sp>
-        <p:nvSpPr>
-          <p:cNvPr id="9" name="TextBox 8"/>
-          <p:cNvSpPr txBox="1"/>
-          <p:nvPr/>
-        </p:nvSpPr>
-        <p:spPr>
-          <a:xfrm>
-            <a:off x="1417320" y="2962656"/>
-            <a:ext cx="10058400" cy="320040"/>
-          </a:xfrm>
-          <a:prstGeom prst="rect">
-            <a:avLst/>
-          </a:prstGeom>
-          <a:noFill/>
-        </p:spPr>
-        <p:txBody>
-          <a:bodyPr wrap="square" anchor="t" lIns="45720" rIns="45720">
-            <a:spAutoFit/>
-          </a:bodyPr>
-          <a:lstStyle/>
-          <a:p>
-            <a:pPr algn="l"/>
-            <a:r>
-              <a:rPr sz="1300" b="0" i="0">
-                <a:solidFill>
-                  <a:srgbClr val="333333"/>
-                </a:solidFill>
-                <a:latin typeface="Calibri"/>
-              </a:rPr>
-              <a:t>Poky + BitBake + layers; you compose your product</a:t>
-            </a:r>
-          </a:p>
-        </p:txBody>
-      </p:sp>
-      <p:sp>
-        <p:nvSpPr>
-          <p:cNvPr id="10" name="Rounded Rectangle 9"/>
-          <p:cNvSpPr/>
-          <p:nvPr/>
-        </p:nvSpPr>
-        <p:spPr>
-          <a:xfrm>
-            <a:off x="822960" y="3429000"/>
-            <a:ext cx="457200" cy="548640"/>
-          </a:xfrm>
-          <a:prstGeom prst="roundRect">
-            <a:avLst/>
-          </a:prstGeom>
-          <a:solidFill>
-            <a:srgbClr val="663399"/>
-          </a:solidFill>
-          <a:ln>
-            <a:noFill/>
-          </a:ln>
-          <a:effectLst/>
-        </p:spPr>
-        <p:style>
-          <a:lnRef idx="1">
-            <a:schemeClr val="accent1"/>
-          </a:lnRef>
-          <a:fillRef idx="3">
-            <a:schemeClr val="accent1"/>
-          </a:fillRef>
-          <a:effectRef idx="2">
-            <a:schemeClr val="accent1"/>
-          </a:effectRef>
-          <a:fontRef idx="minor">
-            <a:schemeClr val="lt1"/>
-          </a:fontRef>
-        </p:style>
-        <p:txBody>
-          <a:bodyPr rtlCol="0" anchor="ctr" lIns="0" rIns="0"/>
-          <a:lstStyle/>
-          <a:p>
-            <a:pPr algn="ctr"/>
-            <a:r>
-              <a:rPr sz="2200" b="1">
-                <a:solidFill>
-                  <a:srgbClr val="FFFFFF"/>
-                </a:solidFill>
-                <a:latin typeface="Calibri"/>
-              </a:rPr>
-              <a:t>3</a:t>
-            </a:r>
-          </a:p>
-        </p:txBody>
-      </p:sp>
-      <p:sp>
-        <p:nvSpPr>
-          <p:cNvPr id="11" name="TextBox 10"/>
-          <p:cNvSpPr txBox="1"/>
-          <p:nvPr/>
-        </p:nvSpPr>
-        <p:spPr>
-          <a:xfrm>
-            <a:off x="1417320" y="3429000"/>
-            <a:ext cx="10058400" cy="320040"/>
-          </a:xfrm>
-          <a:prstGeom prst="rect">
-            <a:avLst/>
-          </a:prstGeom>
-          <a:noFill/>
-        </p:spPr>
-        <p:txBody>
-          <a:bodyPr wrap="square" anchor="t" lIns="45720" rIns="45720">
-            <a:spAutoFit/>
-          </a:bodyPr>
-          <a:lstStyle/>
-          <a:p>
-            <a:pPr algn="l"/>
-            <a:r>
-              <a:rPr sz="1600" b="1" i="0">
-                <a:solidFill>
-                  <a:srgbClr val="CC0066"/>
-                </a:solidFill>
-                <a:latin typeface="Calibri"/>
-              </a:rPr>
-              <a:t>BitBake parses, plans, executes</a:t>
-            </a:r>
-          </a:p>
-        </p:txBody>
-      </p:sp>
-      <p:sp>
-        <p:nvSpPr>
-          <p:cNvPr id="12" name="TextBox 11"/>
-          <p:cNvSpPr txBox="1"/>
-          <p:nvPr/>
-        </p:nvSpPr>
-        <p:spPr>
-          <a:xfrm>
-            <a:off x="1417320" y="3739896"/>
-            <a:ext cx="10058400" cy="320040"/>
-          </a:xfrm>
-          <a:prstGeom prst="rect">
-            <a:avLst/>
-          </a:prstGeom>
-          <a:noFill/>
-        </p:spPr>
-        <p:txBody>
-          <a:bodyPr wrap="square" anchor="t" lIns="45720" rIns="45720">
-            <a:spAutoFit/>
-          </a:bodyPr>
-          <a:lstStyle/>
-          <a:p>
-            <a:pPr algn="l"/>
-            <a:r>
-              <a:rPr sz="1300" b="0" i="0">
-                <a:solidFill>
-                  <a:srgbClr val="333333"/>
-                </a:solidFill>
-                <a:latin typeface="Calibri"/>
-              </a:rPr>
-              <a:t>Task graph + sstate cache = scalable builds</a:t>
-            </a:r>
-          </a:p>
-        </p:txBody>
-      </p:sp>
-      <p:sp>
-        <p:nvSpPr>
-          <p:cNvPr id="13" name="Rounded Rectangle 12"/>
-          <p:cNvSpPr/>
-          <p:nvPr/>
-        </p:nvSpPr>
-        <p:spPr>
-          <a:xfrm>
-            <a:off x="822960" y="4206240"/>
-            <a:ext cx="457200" cy="548640"/>
-          </a:xfrm>
-          <a:prstGeom prst="roundRect">
-            <a:avLst/>
-          </a:prstGeom>
-          <a:solidFill>
-            <a:srgbClr val="663399"/>
-          </a:solidFill>
-          <a:ln>
-            <a:noFill/>
-          </a:ln>
-          <a:effectLst/>
-        </p:spPr>
-        <p:style>
-          <a:lnRef idx="1">
-            <a:schemeClr val="accent1"/>
-          </a:lnRef>
-          <a:fillRef idx="3">
-            <a:schemeClr val="accent1"/>
-          </a:fillRef>
-          <a:effectRef idx="2">
-            <a:schemeClr val="accent1"/>
-          </a:effectRef>
-          <a:fontRef idx="minor">
-            <a:schemeClr val="lt1"/>
-          </a:fontRef>
-        </p:style>
-        <p:txBody>
-          <a:bodyPr rtlCol="0" anchor="ctr" lIns="0" rIns="0"/>
-          <a:lstStyle/>
-          <a:p>
-            <a:pPr algn="ctr"/>
-            <a:r>
-              <a:rPr sz="2200" b="1">
-                <a:solidFill>
-                  <a:srgbClr val="FFFFFF"/>
-                </a:solidFill>
-                <a:latin typeface="Calibri"/>
-              </a:rPr>
-              <a:t>4</a:t>
-            </a:r>
-          </a:p>
-        </p:txBody>
-      </p:sp>
-      <p:sp>
-        <p:nvSpPr>
-          <p:cNvPr id="14" name="TextBox 13"/>
-          <p:cNvSpPr txBox="1"/>
-          <p:nvPr/>
-        </p:nvSpPr>
-        <p:spPr>
-          <a:xfrm>
-            <a:off x="1417320" y="4206240"/>
-            <a:ext cx="10058400" cy="320040"/>
-          </a:xfrm>
-          <a:prstGeom prst="rect">
-            <a:avLst/>
-          </a:prstGeom>
-          <a:noFill/>
-        </p:spPr>
-        <p:txBody>
-          <a:bodyPr wrap="square" anchor="t" lIns="45720" rIns="45720">
-            <a:spAutoFit/>
-          </a:bodyPr>
-          <a:lstStyle/>
-          <a:p>
-            <a:pPr algn="l"/>
-            <a:r>
-              <a:rPr sz="1600" b="1" i="0">
-                <a:solidFill>
-                  <a:srgbClr val="CC0066"/>
-                </a:solidFill>
-                <a:latin typeface="Calibri"/>
-              </a:rPr>
-              <a:t>First custom image built</a:t>
-            </a:r>
-          </a:p>
-        </p:txBody>
-      </p:sp>
-      <p:sp>
-        <p:nvSpPr>
-          <p:cNvPr id="15" name="TextBox 14"/>
-          <p:cNvSpPr txBox="1"/>
-          <p:nvPr/>
-        </p:nvSpPr>
-        <p:spPr>
-          <a:xfrm>
-            <a:off x="1417320" y="4517136"/>
-            <a:ext cx="10058400" cy="320040"/>
-          </a:xfrm>
-          <a:prstGeom prst="rect">
-            <a:avLst/>
-          </a:prstGeom>
-          <a:noFill/>
-        </p:spPr>
-        <p:txBody>
-          <a:bodyPr wrap="square" anchor="t" lIns="45720" rIns="45720">
-            <a:spAutoFit/>
-          </a:bodyPr>
-          <a:lstStyle/>
-          <a:p>
-            <a:pPr algn="l"/>
-            <a:r>
-              <a:rPr sz="1300" b="0" i="0">
-                <a:solidFill>
-                  <a:srgbClr val="333333"/>
-                </a:solidFill>
-                <a:latin typeface="Calibri"/>
-              </a:rPr>
-              <a:t>meta-trainerdemo + hello-trainergw in your IMAGE_INSTALL</a:t>
             </a:r>
           </a:p>
         </p:txBody>

</xml_diff>